<commit_message>
Fix wording in every pack, deck and tracker
</commit_message>
<xml_diff>
--- a/assemblies-and-events/valentines-day-sweet-notes/downloads/Valentines_Day_Sweet_Notes.pptx
+++ b/assemblies-and-events/valentines-day-sweet-notes/downloads/Valentines_Day_Sweet_Notes.pptx
@@ -3289,7 +3289,7 @@
                 </a:solidFill>
                 <a:latin typeface="Karla"/>
               </a:rPr>
-              <a:t>A Valentines Event</a:t>
+              <a:t>A Valentine’s Event</a:t>
             </a:r>
           </a:p>
         </p:txBody>
@@ -4301,7 +4301,7 @@
                 </a:solidFill>
                 <a:latin typeface="Karla"/>
               </a:rPr>
-              <a:t>A Valentines Event</a:t>
+              <a:t>A Valentine’s Event</a:t>
             </a:r>
           </a:p>
         </p:txBody>
@@ -5119,7 +5119,7 @@
                 </a:solidFill>
                 <a:latin typeface="Karla"/>
               </a:rPr>
-              <a:t>A few words and a minute of your time. That is all it costs.</a:t>
+              <a:t>A few words and a minute of your time.</a:t>
             </a:r>
           </a:p>
         </p:txBody>
@@ -6265,7 +6265,7 @@
                 </a:solidFill>
                 <a:latin typeface="Karla"/>
               </a:rPr>
-              <a:t>Come to the stall, write your note, and we do the rest. Every [ PRICE ] goes to [ CHARITY ].</a:t>
+              <a:t>Come to the stall, write your note, and we do the rest. The money raised goes to [ CHARITY ].</a:t>
             </a:r>
           </a:p>
         </p:txBody>
@@ -7531,7 +7531,7 @@
                 </a:solidFill>
                 <a:latin typeface="Karla"/>
               </a:rPr>
-              <a:t>So the person reading it spends the morning thinking about what it says, not about who sent it. That is what makes it work.</a:t>
+              <a:t>So the person reading it thinks about what it says, not who sent it. An adult reads every note before it goes out.</a:t>
             </a:r>
           </a:p>
         </p:txBody>

</xml_diff>

<commit_message>
Planting Project and Sweet Notes photos, and a human pass on copy and layout
</commit_message>
<xml_diff>
--- a/assemblies-and-events/valentines-day-sweet-notes/downloads/Valentines_Day_Sweet_Notes.pptx
+++ b/assemblies-and-events/valentines-day-sweet-notes/downloads/Valentines_Day_Sweet_Notes.pptx
@@ -6526,22 +6526,22 @@
       </p:sp>
       <p:pic>
         <p:nvPicPr>
-          <p:cNvPr id="5" name="Picture 4" descr="bag_plain.png"/>
+          <p:cNvPr id="24" name="Sweet Notes bag photo" descr="deckbag.png"/>
           <p:cNvPicPr>
             <a:picLocks noChangeAspect="1"/>
           </p:cNvPicPr>
           <p:nvPr/>
         </p:nvPicPr>
         <p:blipFill>
-          <a:blip r:embed="rId2"/>
+          <a:blip r:embed="rId4"/>
           <a:stretch>
             <a:fillRect/>
           </a:stretch>
         </p:blipFill>
         <p:spPr>
           <a:xfrm>
-            <a:off x="1005840" y="1664208"/>
-            <a:ext cx="2656928" cy="2798064"/>
+            <a:off x="1048166" y="1664208"/>
+            <a:ext cx="2572275" cy="2798064"/>
           </a:xfrm>
           <a:prstGeom prst="rect">
             <a:avLst/>

</xml_diff>